<commit_message>
updated all template files and replaed the d-space p-space image
</commit_message>
<xml_diff>
--- a/Instats/Day-2/Session-10/open-practical-instats.pptx
+++ b/Instats/Day-2/Session-10/open-practical-instats.pptx
@@ -9,10 +9,8 @@
     <p:sldId id="262" r:id="rId3"/>
     <p:sldId id="263" r:id="rId4"/>
     <p:sldId id="259" r:id="rId5"/>
-    <p:sldId id="258" r:id="rId6"/>
-    <p:sldId id="261" r:id="rId7"/>
-    <p:sldId id="264" r:id="rId8"/>
-    <p:sldId id="260" r:id="rId9"/>
+    <p:sldId id="264" r:id="rId6"/>
+    <p:sldId id="260" r:id="rId7"/>
   </p:sldIdLst>
   <p:sldSz cx="12192000" cy="6858000"/>
   <p:notesSz cx="6858000" cy="9144000"/>
@@ -268,7 +266,7 @@
           <a:p>
             <a:fld id="{287C9ABC-0C1C-4801-85B9-12829D42DDA4}" type="datetimeFigureOut">
               <a:rPr lang="en-AU" smtClean="0"/>
-              <a:t>1/7/2023</a:t>
+              <a:t>24/3/2025</a:t>
             </a:fld>
             <a:endParaRPr lang="en-AU"/>
           </a:p>
@@ -468,7 +466,7 @@
           <a:p>
             <a:fld id="{287C9ABC-0C1C-4801-85B9-12829D42DDA4}" type="datetimeFigureOut">
               <a:rPr lang="en-AU" smtClean="0"/>
-              <a:t>1/7/2023</a:t>
+              <a:t>24/3/2025</a:t>
             </a:fld>
             <a:endParaRPr lang="en-AU"/>
           </a:p>
@@ -678,7 +676,7 @@
           <a:p>
             <a:fld id="{287C9ABC-0C1C-4801-85B9-12829D42DDA4}" type="datetimeFigureOut">
               <a:rPr lang="en-AU" smtClean="0"/>
-              <a:t>1/7/2023</a:t>
+              <a:t>24/3/2025</a:t>
             </a:fld>
             <a:endParaRPr lang="en-AU"/>
           </a:p>
@@ -878,7 +876,7 @@
           <a:p>
             <a:fld id="{287C9ABC-0C1C-4801-85B9-12829D42DDA4}" type="datetimeFigureOut">
               <a:rPr lang="en-AU" smtClean="0"/>
-              <a:t>1/7/2023</a:t>
+              <a:t>24/3/2025</a:t>
             </a:fld>
             <a:endParaRPr lang="en-AU"/>
           </a:p>
@@ -1154,7 +1152,7 @@
           <a:p>
             <a:fld id="{287C9ABC-0C1C-4801-85B9-12829D42DDA4}" type="datetimeFigureOut">
               <a:rPr lang="en-AU" smtClean="0"/>
-              <a:t>1/7/2023</a:t>
+              <a:t>24/3/2025</a:t>
             </a:fld>
             <a:endParaRPr lang="en-AU"/>
           </a:p>
@@ -1422,7 +1420,7 @@
           <a:p>
             <a:fld id="{287C9ABC-0C1C-4801-85B9-12829D42DDA4}" type="datetimeFigureOut">
               <a:rPr lang="en-AU" smtClean="0"/>
-              <a:t>1/7/2023</a:t>
+              <a:t>24/3/2025</a:t>
             </a:fld>
             <a:endParaRPr lang="en-AU"/>
           </a:p>
@@ -1837,7 +1835,7 @@
           <a:p>
             <a:fld id="{287C9ABC-0C1C-4801-85B9-12829D42DDA4}" type="datetimeFigureOut">
               <a:rPr lang="en-AU" smtClean="0"/>
-              <a:t>1/7/2023</a:t>
+              <a:t>24/3/2025</a:t>
             </a:fld>
             <a:endParaRPr lang="en-AU"/>
           </a:p>
@@ -1979,7 +1977,7 @@
           <a:p>
             <a:fld id="{287C9ABC-0C1C-4801-85B9-12829D42DDA4}" type="datetimeFigureOut">
               <a:rPr lang="en-AU" smtClean="0"/>
-              <a:t>1/7/2023</a:t>
+              <a:t>24/3/2025</a:t>
             </a:fld>
             <a:endParaRPr lang="en-AU"/>
           </a:p>
@@ -2092,7 +2090,7 @@
           <a:p>
             <a:fld id="{287C9ABC-0C1C-4801-85B9-12829D42DDA4}" type="datetimeFigureOut">
               <a:rPr lang="en-AU" smtClean="0"/>
-              <a:t>1/7/2023</a:t>
+              <a:t>24/3/2025</a:t>
             </a:fld>
             <a:endParaRPr lang="en-AU"/>
           </a:p>
@@ -2405,7 +2403,7 @@
           <a:p>
             <a:fld id="{287C9ABC-0C1C-4801-85B9-12829D42DDA4}" type="datetimeFigureOut">
               <a:rPr lang="en-AU" smtClean="0"/>
-              <a:t>1/7/2023</a:t>
+              <a:t>24/3/2025</a:t>
             </a:fld>
             <a:endParaRPr lang="en-AU"/>
           </a:p>
@@ -2694,7 +2692,7 @@
           <a:p>
             <a:fld id="{287C9ABC-0C1C-4801-85B9-12829D42DDA4}" type="datetimeFigureOut">
               <a:rPr lang="en-AU" smtClean="0"/>
-              <a:t>1/7/2023</a:t>
+              <a:t>24/3/2025</a:t>
             </a:fld>
             <a:endParaRPr lang="en-AU"/>
           </a:p>
@@ -2937,7 +2935,7 @@
           <a:p>
             <a:fld id="{287C9ABC-0C1C-4801-85B9-12829D42DDA4}" type="datetimeFigureOut">
               <a:rPr lang="en-AU" smtClean="0"/>
-              <a:t>1/7/2023</a:t>
+              <a:t>24/3/2025</a:t>
             </a:fld>
             <a:endParaRPr lang="en-AU"/>
           </a:p>
@@ -3688,7 +3686,7 @@
         </p:spPr>
         <p:txBody>
           <a:bodyPr>
-            <a:normAutofit/>
+            <a:normAutofit fontScale="90000"/>
           </a:bodyPr>
           <a:lstStyle/>
           <a:p>
@@ -3696,7 +3694,7 @@
               <a:rPr lang="en-AU" sz="7200" dirty="0">
                 <a:latin typeface="Montserrat SemiBold" panose="00000700000000000000" pitchFamily="50" charset="0"/>
               </a:rPr>
-              <a:t>Your Seminar Title</a:t>
+              <a:t>Stable Isotope Mixing Models in R</a:t>
             </a:r>
           </a:p>
         </p:txBody>
@@ -3733,7 +3731,7 @@
               <a:rPr lang="en-AU" sz="3600" dirty="0">
                 <a:latin typeface="Montserrat SemiBold" panose="00000700000000000000" pitchFamily="50" charset="0"/>
               </a:rPr>
-              <a:t>Session #: Session Name</a:t>
+              <a:t>Session 10: An open practical session where you can start to explore or analyse your own data</a:t>
             </a:r>
           </a:p>
         </p:txBody>
@@ -3809,214 +3807,6 @@
           <p:cNvPr id="2" name="Title 1">
             <a:extLst>
               <a:ext uri="{FF2B5EF4-FFF2-40B4-BE49-F238E27FC236}">
-                <a16:creationId xmlns:a16="http://schemas.microsoft.com/office/drawing/2014/main" id="{F19E5C1D-AD0B-02C5-92F2-3A516AF1A63E}"/>
-              </a:ext>
-            </a:extLst>
-          </p:cNvPr>
-          <p:cNvSpPr>
-            <a:spLocks noGrp="1"/>
-          </p:cNvSpPr>
-          <p:nvPr>
-            <p:ph type="title"/>
-          </p:nvPr>
-        </p:nvSpPr>
-        <p:spPr/>
-        <p:txBody>
-          <a:bodyPr/>
-          <a:lstStyle/>
-          <a:p>
-            <a:r>
-              <a:rPr lang="en-AU" dirty="0"/>
-              <a:t>Regular workshops content</a:t>
-            </a:r>
-          </a:p>
-        </p:txBody>
-      </p:sp>
-      <p:sp>
-        <p:nvSpPr>
-          <p:cNvPr id="3" name="Content Placeholder 2">
-            <a:extLst>
-              <a:ext uri="{FF2B5EF4-FFF2-40B4-BE49-F238E27FC236}">
-                <a16:creationId xmlns:a16="http://schemas.microsoft.com/office/drawing/2014/main" id="{03B1646F-18ED-868E-4E38-F47A48DA632A}"/>
-              </a:ext>
-            </a:extLst>
-          </p:cNvPr>
-          <p:cNvSpPr>
-            <a:spLocks noGrp="1"/>
-          </p:cNvSpPr>
-          <p:nvPr>
-            <p:ph idx="1"/>
-          </p:nvPr>
-        </p:nvSpPr>
-        <p:spPr/>
-        <p:txBody>
-          <a:bodyPr/>
-          <a:lstStyle/>
-          <a:p>
-            <a:r>
-              <a:rPr lang="en-AU" dirty="0"/>
-              <a:t>Topics we'll cover in this session:</a:t>
-            </a:r>
-          </a:p>
-          <a:p>
-            <a:r>
-              <a:rPr lang="en-AU" dirty="0"/>
-              <a:t>1) …</a:t>
-            </a:r>
-          </a:p>
-          <a:p>
-            <a:r>
-              <a:rPr lang="en-AU" dirty="0"/>
-              <a:t>2) …</a:t>
-            </a:r>
-          </a:p>
-          <a:p>
-            <a:r>
-              <a:rPr lang="en-AU" dirty="0"/>
-              <a:t>…</a:t>
-            </a:r>
-          </a:p>
-        </p:txBody>
-      </p:sp>
-    </p:spTree>
-    <p:extLst>
-      <p:ext uri="{BB962C8B-B14F-4D97-AF65-F5344CB8AC3E}">
-        <p14:creationId xmlns:p14="http://schemas.microsoft.com/office/powerpoint/2010/main" val="2700051097"/>
-      </p:ext>
-    </p:extLst>
-  </p:cSld>
-  <p:clrMapOvr>
-    <a:masterClrMapping/>
-  </p:clrMapOvr>
-</p:sld>
-</file>
-
-<file path=ppt/slides/slide6.xml><?xml version="1.0" encoding="utf-8"?>
-<p:sld xmlns:a="http://schemas.openxmlformats.org/drawingml/2006/main" xmlns:r="http://schemas.openxmlformats.org/officeDocument/2006/relationships" xmlns:p="http://schemas.openxmlformats.org/presentationml/2006/main">
-  <p:cSld>
-    <p:spTree>
-      <p:nvGrpSpPr>
-        <p:cNvPr id="1" name=""/>
-        <p:cNvGrpSpPr/>
-        <p:nvPr/>
-      </p:nvGrpSpPr>
-      <p:grpSpPr>
-        <a:xfrm>
-          <a:off x="0" y="0"/>
-          <a:ext cx="0" cy="0"/>
-          <a:chOff x="0" y="0"/>
-          <a:chExt cx="0" cy="0"/>
-        </a:xfrm>
-      </p:grpSpPr>
-      <p:sp>
-        <p:nvSpPr>
-          <p:cNvPr id="2" name="Title 1">
-            <a:extLst>
-              <a:ext uri="{FF2B5EF4-FFF2-40B4-BE49-F238E27FC236}">
-                <a16:creationId xmlns:a16="http://schemas.microsoft.com/office/drawing/2014/main" id="{F19E5C1D-AD0B-02C5-92F2-3A516AF1A63E}"/>
-              </a:ext>
-            </a:extLst>
-          </p:cNvPr>
-          <p:cNvSpPr>
-            <a:spLocks noGrp="1"/>
-          </p:cNvSpPr>
-          <p:nvPr>
-            <p:ph type="title"/>
-          </p:nvPr>
-        </p:nvSpPr>
-        <p:spPr/>
-        <p:txBody>
-          <a:bodyPr/>
-          <a:lstStyle/>
-          <a:p>
-            <a:r>
-              <a:rPr lang="en-AU" dirty="0"/>
-              <a:t>Last Slide Here</a:t>
-            </a:r>
-          </a:p>
-        </p:txBody>
-      </p:sp>
-      <p:sp>
-        <p:nvSpPr>
-          <p:cNvPr id="3" name="Content Placeholder 2">
-            <a:extLst>
-              <a:ext uri="{FF2B5EF4-FFF2-40B4-BE49-F238E27FC236}">
-                <a16:creationId xmlns:a16="http://schemas.microsoft.com/office/drawing/2014/main" id="{03B1646F-18ED-868E-4E38-F47A48DA632A}"/>
-              </a:ext>
-            </a:extLst>
-          </p:cNvPr>
-          <p:cNvSpPr>
-            <a:spLocks noGrp="1"/>
-          </p:cNvSpPr>
-          <p:nvPr>
-            <p:ph idx="1"/>
-          </p:nvPr>
-        </p:nvSpPr>
-        <p:spPr/>
-        <p:txBody>
-          <a:bodyPr/>
-          <a:lstStyle/>
-          <a:p>
-            <a:r>
-              <a:rPr lang="en-AU" dirty="0"/>
-              <a:t>[Whatever you want to say:] In summary, this session covered</a:t>
-            </a:r>
-          </a:p>
-          <a:p>
-            <a:r>
-              <a:rPr lang="en-AU" dirty="0"/>
-              <a:t>1) …</a:t>
-            </a:r>
-          </a:p>
-          <a:p>
-            <a:r>
-              <a:rPr lang="en-AU" dirty="0"/>
-              <a:t>2) …</a:t>
-            </a:r>
-          </a:p>
-          <a:p>
-            <a:r>
-              <a:rPr lang="en-AU" dirty="0"/>
-              <a:t>…</a:t>
-            </a:r>
-          </a:p>
-        </p:txBody>
-      </p:sp>
-    </p:spTree>
-    <p:extLst>
-      <p:ext uri="{BB962C8B-B14F-4D97-AF65-F5344CB8AC3E}">
-        <p14:creationId xmlns:p14="http://schemas.microsoft.com/office/powerpoint/2010/main" val="2346720206"/>
-      </p:ext>
-    </p:extLst>
-  </p:cSld>
-  <p:clrMapOvr>
-    <a:masterClrMapping/>
-  </p:clrMapOvr>
-</p:sld>
-</file>
-
-<file path=ppt/slides/slide7.xml><?xml version="1.0" encoding="utf-8"?>
-<p:sld xmlns:a="http://schemas.openxmlformats.org/drawingml/2006/main" xmlns:r="http://schemas.openxmlformats.org/officeDocument/2006/relationships" xmlns:p="http://schemas.openxmlformats.org/presentationml/2006/main">
-  <p:cSld>
-    <p:spTree>
-      <p:nvGrpSpPr>
-        <p:cNvPr id="1" name=""/>
-        <p:cNvGrpSpPr/>
-        <p:nvPr/>
-      </p:nvGrpSpPr>
-      <p:grpSpPr>
-        <a:xfrm>
-          <a:off x="0" y="0"/>
-          <a:ext cx="0" cy="0"/>
-          <a:chOff x="0" y="0"/>
-          <a:chExt cx="0" cy="0"/>
-        </a:xfrm>
-      </p:grpSpPr>
-      <p:sp>
-        <p:nvSpPr>
-          <p:cNvPr id="2" name="Title 1">
-            <a:extLst>
-              <a:ext uri="{FF2B5EF4-FFF2-40B4-BE49-F238E27FC236}">
                 <a16:creationId xmlns:a16="http://schemas.microsoft.com/office/drawing/2014/main" id="{19DE3506-1F02-B17A-46C4-65421387E328}"/>
               </a:ext>
             </a:extLst>
@@ -4075,7 +3865,7 @@
 </p:sld>
 </file>
 
-<file path=ppt/slides/slide8.xml><?xml version="1.0" encoding="utf-8"?>
+<file path=ppt/slides/slide6.xml><?xml version="1.0" encoding="utf-8"?>
 <p:sld xmlns:a="http://schemas.openxmlformats.org/drawingml/2006/main" xmlns:r="http://schemas.openxmlformats.org/officeDocument/2006/relationships" xmlns:p="http://schemas.openxmlformats.org/presentationml/2006/main">
   <p:cSld>
     <p:spTree>

</xml_diff>